<commit_message>
chore(docs): refresh the daily-run slide for Sprint 20
- Sprint 20 figures: 130 new tests (83 flights, 11 hotels, 14 transportation,
  22 shell), counted as new .feature files on main since 2026-09-13
- Take the per-domain daily-run counts from the 2026-10-05 morning batch
  (996 tests); the suite-workflow count is printed alongside as a cross-check
- Blocked now counts every .feature file no suite runs (45), not only the
  *_blocked folders
- Round the domain shares so they always add up to 100%
- Widen the highlight value so a three-digit count stays on one line

Co-Authored-By: Claude Opus 5.5 (1M context) <noreply@anthropic.com>
</commit_message>
<xml_diff>
--- a/docs/Test-Automation-Update.pptx
+++ b/docs/Test-Automation-Update.pptx
@@ -272,10 +272,10 @@
               <c:numCache>
                 <c:ptCount val="2"/>
                 <c:pt idx="0">
-                  <c:v>643</c:v>
+                  <c:v>747</c:v>
                 </c:pt>
                 <c:pt idx="1">
-                  <c:v>214</c:v>
+                  <c:v>249</c:v>
                 </c:pt>
               </c:numCache>
             </c:numRef>
@@ -1342,7 +1342,7 @@
                 <a:ea typeface="Calibri" pitchFamily="34" charset="-122"/>
                 <a:cs typeface="Calibri" pitchFamily="34" charset="-120"/>
               </a:rPr>
-              <a:t>857</a:t>
+              <a:t>996</a:t>
             </a:r>
             <a:endParaRPr lang="en-US" sz="3200" dirty="0"/>
           </a:p>
@@ -1552,7 +1552,7 @@
                 <a:ea typeface="Calibri" pitchFamily="34" charset="-122"/>
                 <a:cs typeface="Calibri" pitchFamily="34" charset="-120"/>
               </a:rPr>
-              <a:t>69</a:t>
+              <a:t>45</a:t>
             </a:r>
             <a:endParaRPr lang="en-US" sz="3200" dirty="0"/>
           </a:p>
@@ -1711,7 +1711,7 @@
         <p:spPr>
           <a:xfrm>
             <a:off x="1874520" y="2926080"/>
-            <a:ext cx="1201844" cy="237744"/>
+            <a:ext cx="1216262" cy="237744"/>
           </a:xfrm>
           <a:prstGeom prst="roundRect">
             <a:avLst>
@@ -1762,7 +1762,7 @@
                 <a:ea typeface="Calibri" pitchFamily="34" charset="-122"/>
                 <a:cs typeface="Calibri" pitchFamily="34" charset="-120"/>
               </a:rPr>
-              <a:t>352</a:t>
+              <a:t>414</a:t>
             </a:r>
             <a:endParaRPr lang="en-US" sz="1200" dirty="0"/>
           </a:p>
@@ -1882,7 +1882,7 @@
         <p:spPr>
           <a:xfrm>
             <a:off x="1874520" y="3657600"/>
-            <a:ext cx="406305" cy="237744"/>
+            <a:ext cx="370167" cy="237744"/>
           </a:xfrm>
           <a:prstGeom prst="roundRect">
             <a:avLst>
@@ -1933,7 +1933,7 @@
                 <a:ea typeface="Calibri" pitchFamily="34" charset="-122"/>
                 <a:cs typeface="Calibri" pitchFamily="34" charset="-120"/>
               </a:rPr>
-              <a:t>119</a:t>
+              <a:t>126</a:t>
             </a:r>
             <a:endParaRPr lang="en-US" sz="1200" dirty="0"/>
           </a:p>
@@ -1972,7 +1972,7 @@
                 <a:ea typeface="Calibri" pitchFamily="34" charset="-122"/>
                 <a:cs typeface="Calibri" pitchFamily="34" charset="-120"/>
               </a:rPr>
-              <a:t>14%</a:t>
+              <a:t>13%</a:t>
             </a:r>
             <a:endParaRPr lang="en-US" sz="900" dirty="0"/>
           </a:p>
@@ -2053,7 +2053,7 @@
         <p:spPr>
           <a:xfrm>
             <a:off x="1874520" y="4389120"/>
-            <a:ext cx="751152" cy="237744"/>
+            <a:ext cx="705080" cy="237744"/>
           </a:xfrm>
           <a:prstGeom prst="roundRect">
             <a:avLst>
@@ -2104,7 +2104,7 @@
                 <a:ea typeface="Calibri" pitchFamily="34" charset="-122"/>
                 <a:cs typeface="Calibri" pitchFamily="34" charset="-120"/>
               </a:rPr>
-              <a:t>220</a:t>
+              <a:t>240</a:t>
             </a:r>
             <a:endParaRPr lang="en-US" sz="1200" dirty="0"/>
           </a:p>
@@ -2143,7 +2143,7 @@
                 <a:ea typeface="Calibri" pitchFamily="34" charset="-122"/>
                 <a:cs typeface="Calibri" pitchFamily="34" charset="-120"/>
               </a:rPr>
-              <a:t>26%</a:t>
+              <a:t>24%</a:t>
             </a:r>
             <a:endParaRPr lang="en-US" sz="900" dirty="0"/>
           </a:p>
@@ -2224,7 +2224,7 @@
         <p:spPr>
           <a:xfrm>
             <a:off x="1874520" y="5120640"/>
-            <a:ext cx="566779" cy="237744"/>
+            <a:ext cx="634572" cy="237744"/>
           </a:xfrm>
           <a:prstGeom prst="roundRect">
             <a:avLst>
@@ -2275,7 +2275,7 @@
                 <a:ea typeface="Calibri" pitchFamily="34" charset="-122"/>
                 <a:cs typeface="Calibri" pitchFamily="34" charset="-120"/>
               </a:rPr>
-              <a:t>166</a:t>
+              <a:t>216</a:t>
             </a:r>
             <a:endParaRPr lang="en-US" sz="1200" dirty="0"/>
           </a:p>
@@ -2314,7 +2314,7 @@
                 <a:ea typeface="Calibri" pitchFamily="34" charset="-122"/>
                 <a:cs typeface="Calibri" pitchFamily="34" charset="-120"/>
               </a:rPr>
-              <a:t>19%</a:t>
+              <a:t>22%</a:t>
             </a:r>
             <a:endParaRPr lang="en-US" sz="900" dirty="0"/>
           </a:p>
@@ -2415,7 +2415,7 @@
                 <a:ea typeface="Calibri" pitchFamily="34" charset="-122"/>
                 <a:cs typeface="Calibri" pitchFamily="34" charset="-120"/>
               </a:rPr>
-              <a:t>857 tests</a:t>
+              <a:t>996 tests</a:t>
             </a:r>
             <a:endParaRPr lang="en-US" sz="1300" dirty="0"/>
           </a:p>
@@ -2596,7 +2596,7 @@
                 <a:ea typeface="Calibri" pitchFamily="34" charset="-122"/>
                 <a:cs typeface="Calibri" pitchFamily="34" charset="-120"/>
               </a:rPr>
-              <a:t>Passed  —  643 tests</a:t>
+              <a:t>Passed  —  747 tests</a:t>
             </a:r>
             <a:endParaRPr lang="en-US" sz="1100" dirty="0"/>
           </a:p>
@@ -2660,7 +2660,7 @@
                 <a:ea typeface="Calibri" pitchFamily="34" charset="-122"/>
                 <a:cs typeface="Calibri" pitchFamily="34" charset="-120"/>
               </a:rPr>
-              <a:t>Failed  —  214 tests</a:t>
+              <a:t>Failed  —  249 tests</a:t>
             </a:r>
             <a:endParaRPr lang="en-US" sz="1100" dirty="0"/>
           </a:p>
@@ -2765,7 +2765,7 @@
                 <a:ea typeface="Calibri" pitchFamily="34" charset="-122"/>
                 <a:cs typeface="Calibri" pitchFamily="34" charset="-120"/>
               </a:rPr>
-              <a:t>Coverage added in Sprint 19</a:t>
+              <a:t>Coverage added in Sprint 20</a:t>
             </a:r>
             <a:endParaRPr lang="en-US" sz="1400" dirty="0"/>
           </a:p>
@@ -2779,17 +2779,17 @@
         </p:nvSpPr>
         <p:spPr>
           <a:xfrm>
-            <a:off x="6858000" y="5312664"/>
-            <a:ext cx="457200" cy="310896"/>
-          </a:xfrm>
-          <a:prstGeom prst="rect">
-            <a:avLst/>
-          </a:prstGeom>
-          <a:noFill/>
-          <a:ln/>
-        </p:spPr>
-        <p:txBody>
-          <a:bodyPr wrap="square" rtlCol="0" anchor="ctr"/>
+            <a:off x="6720840" y="5312664"/>
+            <a:ext cx="685800" cy="310896"/>
+          </a:xfrm>
+          <a:prstGeom prst="rect">
+            <a:avLst/>
+          </a:prstGeom>
+          <a:noFill/>
+          <a:ln/>
+        </p:spPr>
+        <p:txBody>
+          <a:bodyPr wrap="none" rtlCol="0" anchor="ctr"/>
           <a:lstStyle/>
           <a:p>
             <a:pPr algn="r" indent="0" marL="0">
@@ -2804,7 +2804,7 @@
                 <a:ea typeface="Calibri" pitchFamily="34" charset="-122"/>
                 <a:cs typeface="Calibri" pitchFamily="34" charset="-120"/>
               </a:rPr>
-              <a:t>32</a:t>
+              <a:t>130</a:t>
             </a:r>
             <a:endParaRPr lang="en-US" sz="2000" dirty="0"/>
           </a:p>
@@ -2882,7 +2882,7 @@
                 <a:ea typeface="Calibri" pitchFamily="34" charset="-122"/>
                 <a:cs typeface="Calibri" pitchFamily="34" charset="-120"/>
               </a:rPr>
-              <a:t>24 </a:t>
+              <a:t>83 </a:t>
             </a:r>
             <a:pPr indent="0" marL="0">
               <a:buNone/>
@@ -2924,7 +2924,7 @@
                 <a:ea typeface="Calibri" pitchFamily="34" charset="-122"/>
                 <a:cs typeface="Calibri" pitchFamily="34" charset="-120"/>
               </a:rPr>
-              <a:t>2 </a:t>
+              <a:t>11 </a:t>
             </a:r>
             <a:pPr indent="0" marL="0">
               <a:buNone/>
@@ -2966,7 +2966,7 @@
                 <a:ea typeface="Calibri" pitchFamily="34" charset="-122"/>
                 <a:cs typeface="Calibri" pitchFamily="34" charset="-120"/>
               </a:rPr>
-              <a:t>2 </a:t>
+              <a:t>14 </a:t>
             </a:r>
             <a:pPr indent="0" marL="0">
               <a:buNone/>
@@ -3008,7 +3008,7 @@
                 <a:ea typeface="Calibri" pitchFamily="34" charset="-122"/>
                 <a:cs typeface="Calibri" pitchFamily="34" charset="-120"/>
               </a:rPr>
-              <a:t>4 </a:t>
+              <a:t>22 </a:t>
             </a:r>
             <a:pPr indent="0" marL="0">
               <a:buNone/>

</xml_diff>

<commit_message>
chore(docs): correct the Sprint 20 figures on the daily-run slide
- Tests running daily: 968 (Flights 421, Hotels 136, Shell 235,
  Transportation 176), the .feature files the four suite workflows pick
  up on main at the end of Sprint 20, replacing the 2026-10-05 batch
  report figures (996) that did not match the suites
- New tests: 82 (45 flights, 13 hotels, 10 transportation, 14 shell),
  net new .feature files during Sprint 20 (2026-09-23 to 2026-10-06);
  the previous 130 counted from 2026-09-13 and double-counted Sprint 19

Co-Authored-By: Claude Opus 5.5 (1M context) <noreply@anthropic.com>
</commit_message>
<xml_diff>
--- a/docs/Test-Automation-Update.pptx
+++ b/docs/Test-Automation-Update.pptx
@@ -272,10 +272,10 @@
               <c:numCache>
                 <c:ptCount val="2"/>
                 <c:pt idx="0">
-                  <c:v>747</c:v>
+                  <c:v>726</c:v>
                 </c:pt>
                 <c:pt idx="1">
-                  <c:v>249</c:v>
+                  <c:v>242</c:v>
                 </c:pt>
               </c:numCache>
             </c:numRef>
@@ -1342,7 +1342,7 @@
                 <a:ea typeface="Calibri" pitchFamily="34" charset="-122"/>
                 <a:cs typeface="Calibri" pitchFamily="34" charset="-120"/>
               </a:rPr>
-              <a:t>996</a:t>
+              <a:t>968</a:t>
             </a:r>
             <a:endParaRPr lang="en-US" sz="3200" dirty="0"/>
           </a:p>
@@ -1552,7 +1552,7 @@
                 <a:ea typeface="Calibri" pitchFamily="34" charset="-122"/>
                 <a:cs typeface="Calibri" pitchFamily="34" charset="-120"/>
               </a:rPr>
-              <a:t>45</a:t>
+              <a:t>43</a:t>
             </a:r>
             <a:endParaRPr lang="en-US" sz="3200" dirty="0"/>
           </a:p>
@@ -1711,7 +1711,7 @@
         <p:spPr>
           <a:xfrm>
             <a:off x="1874520" y="2926080"/>
-            <a:ext cx="1216262" cy="237744"/>
+            <a:ext cx="1272603" cy="237744"/>
           </a:xfrm>
           <a:prstGeom prst="roundRect">
             <a:avLst>
@@ -1762,7 +1762,7 @@
                 <a:ea typeface="Calibri" pitchFamily="34" charset="-122"/>
                 <a:cs typeface="Calibri" pitchFamily="34" charset="-120"/>
               </a:rPr>
-              <a:t>414</a:t>
+              <a:t>421</a:t>
             </a:r>
             <a:endParaRPr lang="en-US" sz="1200" dirty="0"/>
           </a:p>
@@ -1801,7 +1801,7 @@
                 <a:ea typeface="Calibri" pitchFamily="34" charset="-122"/>
                 <a:cs typeface="Calibri" pitchFamily="34" charset="-120"/>
               </a:rPr>
-              <a:t>41%</a:t>
+              <a:t>44%</a:t>
             </a:r>
             <a:endParaRPr lang="en-US" sz="900" dirty="0"/>
           </a:p>
@@ -1882,7 +1882,7 @@
         <p:spPr>
           <a:xfrm>
             <a:off x="1874520" y="3657600"/>
-            <a:ext cx="370167" cy="237744"/>
+            <a:ext cx="411102" cy="237744"/>
           </a:xfrm>
           <a:prstGeom prst="roundRect">
             <a:avLst>
@@ -1933,7 +1933,7 @@
                 <a:ea typeface="Calibri" pitchFamily="34" charset="-122"/>
                 <a:cs typeface="Calibri" pitchFamily="34" charset="-120"/>
               </a:rPr>
-              <a:t>126</a:t>
+              <a:t>136</a:t>
             </a:r>
             <a:endParaRPr lang="en-US" sz="1200" dirty="0"/>
           </a:p>
@@ -1972,7 +1972,7 @@
                 <a:ea typeface="Calibri" pitchFamily="34" charset="-122"/>
                 <a:cs typeface="Calibri" pitchFamily="34" charset="-120"/>
               </a:rPr>
-              <a:t>13%</a:t>
+              <a:t>14%</a:t>
             </a:r>
             <a:endParaRPr lang="en-US" sz="900" dirty="0"/>
           </a:p>
@@ -2053,7 +2053,7 @@
         <p:spPr>
           <a:xfrm>
             <a:off x="1874520" y="4389120"/>
-            <a:ext cx="705080" cy="237744"/>
+            <a:ext cx="710360" cy="237744"/>
           </a:xfrm>
           <a:prstGeom prst="roundRect">
             <a:avLst>
@@ -2104,7 +2104,7 @@
                 <a:ea typeface="Calibri" pitchFamily="34" charset="-122"/>
                 <a:cs typeface="Calibri" pitchFamily="34" charset="-120"/>
               </a:rPr>
-              <a:t>240</a:t>
+              <a:t>235</a:t>
             </a:r>
             <a:endParaRPr lang="en-US" sz="1200" dirty="0"/>
           </a:p>
@@ -2224,7 +2224,7 @@
         <p:spPr>
           <a:xfrm>
             <a:off x="1874520" y="5120640"/>
-            <a:ext cx="634572" cy="237744"/>
+            <a:ext cx="532015" cy="237744"/>
           </a:xfrm>
           <a:prstGeom prst="roundRect">
             <a:avLst>
@@ -2275,7 +2275,7 @@
                 <a:ea typeface="Calibri" pitchFamily="34" charset="-122"/>
                 <a:cs typeface="Calibri" pitchFamily="34" charset="-120"/>
               </a:rPr>
-              <a:t>216</a:t>
+              <a:t>176</a:t>
             </a:r>
             <a:endParaRPr lang="en-US" sz="1200" dirty="0"/>
           </a:p>
@@ -2314,7 +2314,7 @@
                 <a:ea typeface="Calibri" pitchFamily="34" charset="-122"/>
                 <a:cs typeface="Calibri" pitchFamily="34" charset="-120"/>
               </a:rPr>
-              <a:t>22%</a:t>
+              <a:t>18%</a:t>
             </a:r>
             <a:endParaRPr lang="en-US" sz="900" dirty="0"/>
           </a:p>
@@ -2415,7 +2415,7 @@
                 <a:ea typeface="Calibri" pitchFamily="34" charset="-122"/>
                 <a:cs typeface="Calibri" pitchFamily="34" charset="-120"/>
               </a:rPr>
-              <a:t>996 tests</a:t>
+              <a:t>968 tests</a:t>
             </a:r>
             <a:endParaRPr lang="en-US" sz="1300" dirty="0"/>
           </a:p>
@@ -2596,7 +2596,7 @@
                 <a:ea typeface="Calibri" pitchFamily="34" charset="-122"/>
                 <a:cs typeface="Calibri" pitchFamily="34" charset="-120"/>
               </a:rPr>
-              <a:t>Passed  —  747 tests</a:t>
+              <a:t>Passed  —  726 tests</a:t>
             </a:r>
             <a:endParaRPr lang="en-US" sz="1100" dirty="0"/>
           </a:p>
@@ -2660,7 +2660,7 @@
                 <a:ea typeface="Calibri" pitchFamily="34" charset="-122"/>
                 <a:cs typeface="Calibri" pitchFamily="34" charset="-120"/>
               </a:rPr>
-              <a:t>Failed  —  249 tests</a:t>
+              <a:t>Failed  —  242 tests</a:t>
             </a:r>
             <a:endParaRPr lang="en-US" sz="1100" dirty="0"/>
           </a:p>
@@ -2804,7 +2804,7 @@
                 <a:ea typeface="Calibri" pitchFamily="34" charset="-122"/>
                 <a:cs typeface="Calibri" pitchFamily="34" charset="-120"/>
               </a:rPr>
-              <a:t>130</a:t>
+              <a:t>82</a:t>
             </a:r>
             <a:endParaRPr lang="en-US" sz="2000" dirty="0"/>
           </a:p>
@@ -2882,7 +2882,7 @@
                 <a:ea typeface="Calibri" pitchFamily="34" charset="-122"/>
                 <a:cs typeface="Calibri" pitchFamily="34" charset="-120"/>
               </a:rPr>
-              <a:t>83 </a:t>
+              <a:t>45 </a:t>
             </a:r>
             <a:pPr indent="0" marL="0">
               <a:buNone/>
@@ -2924,7 +2924,7 @@
                 <a:ea typeface="Calibri" pitchFamily="34" charset="-122"/>
                 <a:cs typeface="Calibri" pitchFamily="34" charset="-120"/>
               </a:rPr>
-              <a:t>11 </a:t>
+              <a:t>13 </a:t>
             </a:r>
             <a:pPr indent="0" marL="0">
               <a:buNone/>
@@ -2966,49 +2966,49 @@
                 <a:ea typeface="Calibri" pitchFamily="34" charset="-122"/>
                 <a:cs typeface="Calibri" pitchFamily="34" charset="-120"/>
               </a:rPr>
+              <a:t>10 </a:t>
+            </a:r>
+            <a:pPr indent="0" marL="0">
+              <a:buNone/>
+            </a:pPr>
+            <a:r>
+              <a:rPr lang="en-US" sz="1100" dirty="0">
+                <a:solidFill>
+                  <a:srgbClr val="6B7280"/>
+                </a:solidFill>
+                <a:latin typeface="Calibri" pitchFamily="34" charset="0"/>
+                <a:ea typeface="Calibri" pitchFamily="34" charset="-122"/>
+                <a:cs typeface="Calibri" pitchFamily="34" charset="-120"/>
+              </a:rPr>
+              <a:t>Transportation</a:t>
+            </a:r>
+            <a:pPr indent="0" marL="0">
+              <a:buNone/>
+            </a:pPr>
+            <a:r>
+              <a:rPr lang="en-US" sz="1100" dirty="0">
+                <a:solidFill>
+                  <a:srgbClr val="E5E7EB"/>
+                </a:solidFill>
+                <a:latin typeface="Calibri" pitchFamily="34" charset="0"/>
+                <a:ea typeface="Calibri" pitchFamily="34" charset="-122"/>
+                <a:cs typeface="Calibri" pitchFamily="34" charset="-120"/>
+              </a:rPr>
+              <a:t>   ·   </a:t>
+            </a:r>
+            <a:pPr indent="0" marL="0">
+              <a:buNone/>
+            </a:pPr>
+            <a:r>
+              <a:rPr lang="en-US" sz="1100" b="1" dirty="0">
+                <a:solidFill>
+                  <a:srgbClr val="10B981"/>
+                </a:solidFill>
+                <a:latin typeface="Calibri" pitchFamily="34" charset="0"/>
+                <a:ea typeface="Calibri" pitchFamily="34" charset="-122"/>
+                <a:cs typeface="Calibri" pitchFamily="34" charset="-120"/>
+              </a:rPr>
               <a:t>14 </a:t>
-            </a:r>
-            <a:pPr indent="0" marL="0">
-              <a:buNone/>
-            </a:pPr>
-            <a:r>
-              <a:rPr lang="en-US" sz="1100" dirty="0">
-                <a:solidFill>
-                  <a:srgbClr val="6B7280"/>
-                </a:solidFill>
-                <a:latin typeface="Calibri" pitchFamily="34" charset="0"/>
-                <a:ea typeface="Calibri" pitchFamily="34" charset="-122"/>
-                <a:cs typeface="Calibri" pitchFamily="34" charset="-120"/>
-              </a:rPr>
-              <a:t>Transportation</a:t>
-            </a:r>
-            <a:pPr indent="0" marL="0">
-              <a:buNone/>
-            </a:pPr>
-            <a:r>
-              <a:rPr lang="en-US" sz="1100" dirty="0">
-                <a:solidFill>
-                  <a:srgbClr val="E5E7EB"/>
-                </a:solidFill>
-                <a:latin typeface="Calibri" pitchFamily="34" charset="0"/>
-                <a:ea typeface="Calibri" pitchFamily="34" charset="-122"/>
-                <a:cs typeface="Calibri" pitchFamily="34" charset="-120"/>
-              </a:rPr>
-              <a:t>   ·   </a:t>
-            </a:r>
-            <a:pPr indent="0" marL="0">
-              <a:buNone/>
-            </a:pPr>
-            <a:r>
-              <a:rPr lang="en-US" sz="1100" b="1" dirty="0">
-                <a:solidFill>
-                  <a:srgbClr val="10B981"/>
-                </a:solidFill>
-                <a:latin typeface="Calibri" pitchFamily="34" charset="0"/>
-                <a:ea typeface="Calibri" pitchFamily="34" charset="-122"/>
-                <a:cs typeface="Calibri" pitchFamily="34" charset="-120"/>
-              </a:rPr>
-              <a:t>22 </a:t>
             </a:r>
             <a:pPr indent="0" marL="0">
               <a:buNone/>

</xml_diff>

<commit_message>
chore(docs): show Sprint 20 daily-run growth as the new-tests figure
- New tests: 86 (45 flights, 17 hotels, 10 transportation, 14 shell),
  the growth of the daily run from the end of Sprint 19 (882) to the end
  of Sprint 20 (968), so the card matches the domain bars; includes the
  tests moved out of blocked folders into the run

Co-Authored-By: Claude Opus 5.5 (1M context) <noreply@anthropic.com>
</commit_message>
<xml_diff>
--- a/docs/Test-Automation-Update.pptx
+++ b/docs/Test-Automation-Update.pptx
@@ -2804,7 +2804,7 @@
                 <a:ea typeface="Calibri" pitchFamily="34" charset="-122"/>
                 <a:cs typeface="Calibri" pitchFamily="34" charset="-120"/>
               </a:rPr>
-              <a:t>82</a:t>
+              <a:t>86</a:t>
             </a:r>
             <a:endParaRPr lang="en-US" sz="2000" dirty="0"/>
           </a:p>
@@ -2924,7 +2924,7 @@
                 <a:ea typeface="Calibri" pitchFamily="34" charset="-122"/>
                 <a:cs typeface="Calibri" pitchFamily="34" charset="-120"/>
               </a:rPr>
-              <a:t>13 </a:t>
+              <a:t>17 </a:t>
             </a:r>
             <a:pPr indent="0" marL="0">
               <a:buNone/>

</xml_diff>

<commit_message>
chore(docs): refresh the Sprint 20 slide with today's added tests
- Tests running daily: 977 (Flights 425, Hotels 138, Shell 238,
  Transportation 176), after nine tests merged on 2026-10-06
- New tests: 95 (49 flights, 19 hotels, 10 transportation, 17 shell),
  the daily-run growth since the end of Sprint 19 (882)

Co-Authored-By: Claude Opus 5.5 (1M context) <noreply@anthropic.com>
</commit_message>
<xml_diff>
--- a/docs/Test-Automation-Update.pptx
+++ b/docs/Test-Automation-Update.pptx
@@ -272,10 +272,10 @@
               <c:numCache>
                 <c:ptCount val="2"/>
                 <c:pt idx="0">
-                  <c:v>726</c:v>
+                  <c:v>733</c:v>
                 </c:pt>
                 <c:pt idx="1">
-                  <c:v>242</c:v>
+                  <c:v>244</c:v>
                 </c:pt>
               </c:numCache>
             </c:numRef>
@@ -1342,7 +1342,7 @@
                 <a:ea typeface="Calibri" pitchFamily="34" charset="-122"/>
                 <a:cs typeface="Calibri" pitchFamily="34" charset="-120"/>
               </a:rPr>
-              <a:t>968</a:t>
+              <a:t>977</a:t>
             </a:r>
             <a:endParaRPr lang="en-US" sz="3200" dirty="0"/>
           </a:p>
@@ -1552,7 +1552,7 @@
                 <a:ea typeface="Calibri" pitchFamily="34" charset="-122"/>
                 <a:cs typeface="Calibri" pitchFamily="34" charset="-120"/>
               </a:rPr>
-              <a:t>43</a:t>
+              <a:t>42</a:t>
             </a:r>
             <a:endParaRPr lang="en-US" sz="3200" dirty="0"/>
           </a:p>
@@ -1711,7 +1711,7 @@
         <p:spPr>
           <a:xfrm>
             <a:off x="1874520" y="2926080"/>
-            <a:ext cx="1272603" cy="237744"/>
+            <a:ext cx="1272860" cy="237744"/>
           </a:xfrm>
           <a:prstGeom prst="roundRect">
             <a:avLst>
@@ -1762,7 +1762,7 @@
                 <a:ea typeface="Calibri" pitchFamily="34" charset="-122"/>
                 <a:cs typeface="Calibri" pitchFamily="34" charset="-120"/>
               </a:rPr>
-              <a:t>421</a:t>
+              <a:t>425</a:t>
             </a:r>
             <a:endParaRPr lang="en-US" sz="1200" dirty="0"/>
           </a:p>
@@ -1882,7 +1882,7 @@
         <p:spPr>
           <a:xfrm>
             <a:off x="1874520" y="3657600"/>
-            <a:ext cx="411102" cy="237744"/>
+            <a:ext cx="413305" cy="237744"/>
           </a:xfrm>
           <a:prstGeom prst="roundRect">
             <a:avLst>
@@ -1933,7 +1933,7 @@
                 <a:ea typeface="Calibri" pitchFamily="34" charset="-122"/>
                 <a:cs typeface="Calibri" pitchFamily="34" charset="-120"/>
               </a:rPr>
-              <a:t>136</a:t>
+              <a:t>138</a:t>
             </a:r>
             <a:endParaRPr lang="en-US" sz="1200" dirty="0"/>
           </a:p>
@@ -2053,7 +2053,7 @@
         <p:spPr>
           <a:xfrm>
             <a:off x="1874520" y="4389120"/>
-            <a:ext cx="710360" cy="237744"/>
+            <a:ext cx="712801" cy="237744"/>
           </a:xfrm>
           <a:prstGeom prst="roundRect">
             <a:avLst>
@@ -2104,7 +2104,7 @@
                 <a:ea typeface="Calibri" pitchFamily="34" charset="-122"/>
                 <a:cs typeface="Calibri" pitchFamily="34" charset="-120"/>
               </a:rPr>
-              <a:t>235</a:t>
+              <a:t>238</a:t>
             </a:r>
             <a:endParaRPr lang="en-US" sz="1200" dirty="0"/>
           </a:p>
@@ -2224,7 +2224,7 @@
         <p:spPr>
           <a:xfrm>
             <a:off x="1874520" y="5120640"/>
-            <a:ext cx="532015" cy="237744"/>
+            <a:ext cx="527114" cy="237744"/>
           </a:xfrm>
           <a:prstGeom prst="roundRect">
             <a:avLst>
@@ -2415,7 +2415,7 @@
                 <a:ea typeface="Calibri" pitchFamily="34" charset="-122"/>
                 <a:cs typeface="Calibri" pitchFamily="34" charset="-120"/>
               </a:rPr>
-              <a:t>968 tests</a:t>
+              <a:t>977 tests</a:t>
             </a:r>
             <a:endParaRPr lang="en-US" sz="1300" dirty="0"/>
           </a:p>
@@ -2596,7 +2596,7 @@
                 <a:ea typeface="Calibri" pitchFamily="34" charset="-122"/>
                 <a:cs typeface="Calibri" pitchFamily="34" charset="-120"/>
               </a:rPr>
-              <a:t>Passed  —  726 tests</a:t>
+              <a:t>Passed  —  733 tests</a:t>
             </a:r>
             <a:endParaRPr lang="en-US" sz="1100" dirty="0"/>
           </a:p>
@@ -2660,7 +2660,7 @@
                 <a:ea typeface="Calibri" pitchFamily="34" charset="-122"/>
                 <a:cs typeface="Calibri" pitchFamily="34" charset="-120"/>
               </a:rPr>
-              <a:t>Failed  —  242 tests</a:t>
+              <a:t>Failed  —  244 tests</a:t>
             </a:r>
             <a:endParaRPr lang="en-US" sz="1100" dirty="0"/>
           </a:p>
@@ -2804,7 +2804,7 @@
                 <a:ea typeface="Calibri" pitchFamily="34" charset="-122"/>
                 <a:cs typeface="Calibri" pitchFamily="34" charset="-120"/>
               </a:rPr>
-              <a:t>86</a:t>
+              <a:t>95</a:t>
             </a:r>
             <a:endParaRPr lang="en-US" sz="2000" dirty="0"/>
           </a:p>
@@ -2882,7 +2882,7 @@
                 <a:ea typeface="Calibri" pitchFamily="34" charset="-122"/>
                 <a:cs typeface="Calibri" pitchFamily="34" charset="-120"/>
               </a:rPr>
-              <a:t>45 </a:t>
+              <a:t>49 </a:t>
             </a:r>
             <a:pPr indent="0" marL="0">
               <a:buNone/>
@@ -2924,91 +2924,91 @@
                 <a:ea typeface="Calibri" pitchFamily="34" charset="-122"/>
                 <a:cs typeface="Calibri" pitchFamily="34" charset="-120"/>
               </a:rPr>
+              <a:t>19 </a:t>
+            </a:r>
+            <a:pPr indent="0" marL="0">
+              <a:buNone/>
+            </a:pPr>
+            <a:r>
+              <a:rPr lang="en-US" sz="1100" dirty="0">
+                <a:solidFill>
+                  <a:srgbClr val="6B7280"/>
+                </a:solidFill>
+                <a:latin typeface="Calibri" pitchFamily="34" charset="0"/>
+                <a:ea typeface="Calibri" pitchFamily="34" charset="-122"/>
+                <a:cs typeface="Calibri" pitchFamily="34" charset="-120"/>
+              </a:rPr>
+              <a:t>Hotels</a:t>
+            </a:r>
+            <a:pPr indent="0" marL="0">
+              <a:buNone/>
+            </a:pPr>
+            <a:r>
+              <a:rPr lang="en-US" sz="1100" dirty="0">
+                <a:solidFill>
+                  <a:srgbClr val="E5E7EB"/>
+                </a:solidFill>
+                <a:latin typeface="Calibri" pitchFamily="34" charset="0"/>
+                <a:ea typeface="Calibri" pitchFamily="34" charset="-122"/>
+                <a:cs typeface="Calibri" pitchFamily="34" charset="-120"/>
+              </a:rPr>
+              <a:t>   ·   </a:t>
+            </a:r>
+            <a:pPr indent="0" marL="0">
+              <a:buNone/>
+            </a:pPr>
+            <a:r>
+              <a:rPr lang="en-US" sz="1100" b="1" dirty="0">
+                <a:solidFill>
+                  <a:srgbClr val="10B981"/>
+                </a:solidFill>
+                <a:latin typeface="Calibri" pitchFamily="34" charset="0"/>
+                <a:ea typeface="Calibri" pitchFamily="34" charset="-122"/>
+                <a:cs typeface="Calibri" pitchFamily="34" charset="-120"/>
+              </a:rPr>
+              <a:t>10 </a:t>
+            </a:r>
+            <a:pPr indent="0" marL="0">
+              <a:buNone/>
+            </a:pPr>
+            <a:r>
+              <a:rPr lang="en-US" sz="1100" dirty="0">
+                <a:solidFill>
+                  <a:srgbClr val="6B7280"/>
+                </a:solidFill>
+                <a:latin typeface="Calibri" pitchFamily="34" charset="0"/>
+                <a:ea typeface="Calibri" pitchFamily="34" charset="-122"/>
+                <a:cs typeface="Calibri" pitchFamily="34" charset="-120"/>
+              </a:rPr>
+              <a:t>Transportation</a:t>
+            </a:r>
+            <a:pPr indent="0" marL="0">
+              <a:buNone/>
+            </a:pPr>
+            <a:r>
+              <a:rPr lang="en-US" sz="1100" dirty="0">
+                <a:solidFill>
+                  <a:srgbClr val="E5E7EB"/>
+                </a:solidFill>
+                <a:latin typeface="Calibri" pitchFamily="34" charset="0"/>
+                <a:ea typeface="Calibri" pitchFamily="34" charset="-122"/>
+                <a:cs typeface="Calibri" pitchFamily="34" charset="-120"/>
+              </a:rPr>
+              <a:t>   ·   </a:t>
+            </a:r>
+            <a:pPr indent="0" marL="0">
+              <a:buNone/>
+            </a:pPr>
+            <a:r>
+              <a:rPr lang="en-US" sz="1100" b="1" dirty="0">
+                <a:solidFill>
+                  <a:srgbClr val="10B981"/>
+                </a:solidFill>
+                <a:latin typeface="Calibri" pitchFamily="34" charset="0"/>
+                <a:ea typeface="Calibri" pitchFamily="34" charset="-122"/>
+                <a:cs typeface="Calibri" pitchFamily="34" charset="-120"/>
+              </a:rPr>
               <a:t>17 </a:t>
-            </a:r>
-            <a:pPr indent="0" marL="0">
-              <a:buNone/>
-            </a:pPr>
-            <a:r>
-              <a:rPr lang="en-US" sz="1100" dirty="0">
-                <a:solidFill>
-                  <a:srgbClr val="6B7280"/>
-                </a:solidFill>
-                <a:latin typeface="Calibri" pitchFamily="34" charset="0"/>
-                <a:ea typeface="Calibri" pitchFamily="34" charset="-122"/>
-                <a:cs typeface="Calibri" pitchFamily="34" charset="-120"/>
-              </a:rPr>
-              <a:t>Hotels</a:t>
-            </a:r>
-            <a:pPr indent="0" marL="0">
-              <a:buNone/>
-            </a:pPr>
-            <a:r>
-              <a:rPr lang="en-US" sz="1100" dirty="0">
-                <a:solidFill>
-                  <a:srgbClr val="E5E7EB"/>
-                </a:solidFill>
-                <a:latin typeface="Calibri" pitchFamily="34" charset="0"/>
-                <a:ea typeface="Calibri" pitchFamily="34" charset="-122"/>
-                <a:cs typeface="Calibri" pitchFamily="34" charset="-120"/>
-              </a:rPr>
-              <a:t>   ·   </a:t>
-            </a:r>
-            <a:pPr indent="0" marL="0">
-              <a:buNone/>
-            </a:pPr>
-            <a:r>
-              <a:rPr lang="en-US" sz="1100" b="1" dirty="0">
-                <a:solidFill>
-                  <a:srgbClr val="10B981"/>
-                </a:solidFill>
-                <a:latin typeface="Calibri" pitchFamily="34" charset="0"/>
-                <a:ea typeface="Calibri" pitchFamily="34" charset="-122"/>
-                <a:cs typeface="Calibri" pitchFamily="34" charset="-120"/>
-              </a:rPr>
-              <a:t>10 </a:t>
-            </a:r>
-            <a:pPr indent="0" marL="0">
-              <a:buNone/>
-            </a:pPr>
-            <a:r>
-              <a:rPr lang="en-US" sz="1100" dirty="0">
-                <a:solidFill>
-                  <a:srgbClr val="6B7280"/>
-                </a:solidFill>
-                <a:latin typeface="Calibri" pitchFamily="34" charset="0"/>
-                <a:ea typeface="Calibri" pitchFamily="34" charset="-122"/>
-                <a:cs typeface="Calibri" pitchFamily="34" charset="-120"/>
-              </a:rPr>
-              <a:t>Transportation</a:t>
-            </a:r>
-            <a:pPr indent="0" marL="0">
-              <a:buNone/>
-            </a:pPr>
-            <a:r>
-              <a:rPr lang="en-US" sz="1100" dirty="0">
-                <a:solidFill>
-                  <a:srgbClr val="E5E7EB"/>
-                </a:solidFill>
-                <a:latin typeface="Calibri" pitchFamily="34" charset="0"/>
-                <a:ea typeface="Calibri" pitchFamily="34" charset="-122"/>
-                <a:cs typeface="Calibri" pitchFamily="34" charset="-120"/>
-              </a:rPr>
-              <a:t>   ·   </a:t>
-            </a:r>
-            <a:pPr indent="0" marL="0">
-              <a:buNone/>
-            </a:pPr>
-            <a:r>
-              <a:rPr lang="en-US" sz="1100" b="1" dirty="0">
-                <a:solidFill>
-                  <a:srgbClr val="10B981"/>
-                </a:solidFill>
-                <a:latin typeface="Calibri" pitchFamily="34" charset="0"/>
-                <a:ea typeface="Calibri" pitchFamily="34" charset="-122"/>
-                <a:cs typeface="Calibri" pitchFamily="34" charset="-120"/>
-              </a:rPr>
-              <a:t>14 </a:t>
             </a:r>
             <a:pPr indent="0" marL="0">
               <a:buNone/>

</xml_diff>